<commit_message>
Add Have to → Want to slides targeting 40s women
Two new slides illustrating the shift from obligation-based thinking
to intrinsic motivation, with relatable examples for women in their 40s.

Co-Authored-By: Claude Sonnet 4.6 <noreply@anthropic.com>
Claude-Session: https://claude.ai/code/session_01MSXNEYW7vm4z41W4VhXmu3
</commit_message>
<xml_diff>
--- a/ファスティング指導士_カウンセリング講義スライド.pptx
+++ b/ファスティング指導士_カウンセリング講義スライド.pptx
@@ -18,6 +18,8 @@
     <p:sldId id="266" r:id="rId17"/>
     <p:sldId id="267" r:id="rId18"/>
     <p:sldId id="268" r:id="rId19"/>
+    <p:sldId id="269" r:id="rId20"/>
+    <p:sldId id="270" r:id="rId21"/>
   </p:sldIdLst>
   <p:sldSz cx="12188952" cy="6858000" type="screen4x3"/>
   <p:notesSz cx="6858000" cy="9144000"/>
@@ -7344,6 +7346,2349 @@
                 </a:solidFill>
               </a:rPr>
               <a:t>悩みに気づかせ、なりたい自分を見つける場 ── それがカウンセリングの真髄</a:t>
+            </a:r>
+          </a:p>
+        </p:txBody>
+      </p:sp>
+    </p:spTree>
+  </p:cSld>
+  <p:clrMapOvr>
+    <a:masterClrMapping/>
+  </p:clrMapOvr>
+</p:sld>
+</file>
+
+<file path=ppt/slides/slide14.xml><?xml version="1.0" encoding="utf-8"?>
+<p:sld xmlns:a="http://schemas.openxmlformats.org/drawingml/2006/main" xmlns:p="http://schemas.openxmlformats.org/presentationml/2006/main" xmlns:r="http://schemas.openxmlformats.org/officeDocument/2006/relationships">
+  <p:cSld>
+    <p:spTree>
+      <p:nvGrpSpPr>
+        <p:cNvPr id="1" name=""/>
+        <p:cNvGrpSpPr/>
+        <p:nvPr/>
+      </p:nvGrpSpPr>
+      <p:grpSpPr/>
+      <p:sp>
+        <p:nvSpPr>
+          <p:cNvPr id="2" name="Rectangle 1"/>
+          <p:cNvSpPr/>
+          <p:nvPr/>
+        </p:nvSpPr>
+        <p:spPr>
+          <a:xfrm>
+            <a:off x="0" y="0"/>
+            <a:ext cx="12188952" cy="6858000"/>
+          </a:xfrm>
+          <a:prstGeom prst="rect">
+            <a:avLst/>
+          </a:prstGeom>
+          <a:solidFill>
+            <a:srgbClr val="FDF6FF"/>
+          </a:solidFill>
+          <a:ln>
+            <a:noFill/>
+          </a:ln>
+        </p:spPr>
+        <p:style>
+          <a:lnRef idx="1">
+            <a:schemeClr val="accent1"/>
+          </a:lnRef>
+          <a:fillRef idx="3">
+            <a:schemeClr val="accent1"/>
+          </a:fillRef>
+          <a:effectRef idx="2">
+            <a:schemeClr val="accent1"/>
+          </a:effectRef>
+          <a:fontRef idx="minor">
+            <a:schemeClr val="lt1"/>
+          </a:fontRef>
+        </p:style>
+        <p:txBody>
+          <a:bodyPr rtlCol="0" anchor="ctr"/>
+          <a:lstStyle/>
+          <a:p>
+            <a:pPr algn="ctr"/>
+          </a:p>
+        </p:txBody>
+      </p:sp>
+      <p:sp>
+        <p:nvSpPr>
+          <p:cNvPr id="3" name="Rectangle 2"/>
+          <p:cNvSpPr/>
+          <p:nvPr/>
+        </p:nvSpPr>
+        <p:spPr>
+          <a:xfrm>
+            <a:off x="0" y="0"/>
+            <a:ext cx="12188952" cy="1051560"/>
+          </a:xfrm>
+          <a:prstGeom prst="rect">
+            <a:avLst/>
+          </a:prstGeom>
+          <a:solidFill>
+            <a:srgbClr val="6A1B9A"/>
+          </a:solidFill>
+          <a:ln>
+            <a:noFill/>
+          </a:ln>
+        </p:spPr>
+        <p:style>
+          <a:lnRef idx="1">
+            <a:schemeClr val="accent1"/>
+          </a:lnRef>
+          <a:fillRef idx="3">
+            <a:schemeClr val="accent1"/>
+          </a:fillRef>
+          <a:effectRef idx="2">
+            <a:schemeClr val="accent1"/>
+          </a:effectRef>
+          <a:fontRef idx="minor">
+            <a:schemeClr val="lt1"/>
+          </a:fontRef>
+        </p:style>
+        <p:txBody>
+          <a:bodyPr rtlCol="0" anchor="ctr"/>
+          <a:lstStyle/>
+          <a:p>
+            <a:pPr algn="ctr"/>
+          </a:p>
+        </p:txBody>
+      </p:sp>
+      <p:sp>
+        <p:nvSpPr>
+          <p:cNvPr id="4" name="TextBox 3"/>
+          <p:cNvSpPr txBox="1"/>
+          <p:nvPr/>
+        </p:nvSpPr>
+        <p:spPr>
+          <a:xfrm>
+            <a:off x="365760" y="164592"/>
+            <a:ext cx="11430000" cy="731520"/>
+          </a:xfrm>
+          <a:prstGeom prst="rect">
+            <a:avLst/>
+          </a:prstGeom>
+          <a:noFill/>
+        </p:spPr>
+        <p:txBody>
+          <a:bodyPr wrap="square">
+            <a:spAutoFit/>
+          </a:bodyPr>
+          <a:lstStyle/>
+          <a:p>
+            <a:pPr algn="l"/>
+            <a:r>
+              <a:rPr sz="2300" b="1" i="0">
+                <a:solidFill>
+                  <a:srgbClr val="FFFFFF"/>
+                </a:solidFill>
+              </a:rPr>
+              <a:t>カウンセリングが変える「動き方」── Have to から Want to へ</a:t>
+            </a:r>
+          </a:p>
+        </p:txBody>
+      </p:sp>
+      <p:sp>
+        <p:nvSpPr>
+          <p:cNvPr id="5" name="Rectangle 4"/>
+          <p:cNvSpPr/>
+          <p:nvPr/>
+        </p:nvSpPr>
+        <p:spPr>
+          <a:xfrm>
+            <a:off x="365760" y="1143000"/>
+            <a:ext cx="11430000" cy="502920"/>
+          </a:xfrm>
+          <a:prstGeom prst="rect">
+            <a:avLst/>
+          </a:prstGeom>
+          <a:solidFill>
+            <a:srgbClr val="EEE0F7"/>
+          </a:solidFill>
+          <a:ln>
+            <a:noFill/>
+          </a:ln>
+        </p:spPr>
+        <p:style>
+          <a:lnRef idx="1">
+            <a:schemeClr val="accent1"/>
+          </a:lnRef>
+          <a:fillRef idx="3">
+            <a:schemeClr val="accent1"/>
+          </a:fillRef>
+          <a:effectRef idx="2">
+            <a:schemeClr val="accent1"/>
+          </a:effectRef>
+          <a:fontRef idx="minor">
+            <a:schemeClr val="lt1"/>
+          </a:fontRef>
+        </p:style>
+        <p:txBody>
+          <a:bodyPr rtlCol="0" anchor="ctr"/>
+          <a:lstStyle/>
+          <a:p>
+            <a:pPr algn="ctr"/>
+          </a:p>
+        </p:txBody>
+      </p:sp>
+      <p:sp>
+        <p:nvSpPr>
+          <p:cNvPr id="6" name="TextBox 5"/>
+          <p:cNvSpPr txBox="1"/>
+          <p:nvPr/>
+        </p:nvSpPr>
+        <p:spPr>
+          <a:xfrm>
+            <a:off x="457200" y="1170432"/>
+            <a:ext cx="11155680" cy="438912"/>
+          </a:xfrm>
+          <a:prstGeom prst="rect">
+            <a:avLst/>
+          </a:prstGeom>
+          <a:noFill/>
+        </p:spPr>
+        <p:txBody>
+          <a:bodyPr wrap="square">
+            <a:spAutoFit/>
+          </a:bodyPr>
+          <a:lstStyle/>
+          <a:p>
+            <a:pPr algn="ctr"/>
+            <a:r>
+              <a:rPr sz="1600" b="1" i="0">
+                <a:solidFill>
+                  <a:srgbClr val="6A1B9A"/>
+                </a:solidFill>
+              </a:rPr>
+              <a:t>── 40代になって、こんな経験ありませんか？ ──</a:t>
+            </a:r>
+          </a:p>
+        </p:txBody>
+      </p:sp>
+      <p:sp>
+        <p:nvSpPr>
+          <p:cNvPr id="7" name="Rectangle 6"/>
+          <p:cNvSpPr/>
+          <p:nvPr/>
+        </p:nvSpPr>
+        <p:spPr>
+          <a:xfrm>
+            <a:off x="457200" y="1783080"/>
+            <a:ext cx="3566160" cy="1371600"/>
+          </a:xfrm>
+          <a:prstGeom prst="rect">
+            <a:avLst/>
+          </a:prstGeom>
+          <a:solidFill>
+            <a:srgbClr val="FFE0EB"/>
+          </a:solidFill>
+          <a:ln w="12700">
+            <a:solidFill>
+              <a:srgbClr val="6A1B9A"/>
+            </a:solidFill>
+          </a:ln>
+        </p:spPr>
+        <p:style>
+          <a:lnRef idx="1">
+            <a:schemeClr val="accent1"/>
+          </a:lnRef>
+          <a:fillRef idx="3">
+            <a:schemeClr val="accent1"/>
+          </a:fillRef>
+          <a:effectRef idx="2">
+            <a:schemeClr val="accent1"/>
+          </a:effectRef>
+          <a:fontRef idx="minor">
+            <a:schemeClr val="lt1"/>
+          </a:fontRef>
+        </p:style>
+        <p:txBody>
+          <a:bodyPr rtlCol="0" anchor="ctr"/>
+          <a:lstStyle/>
+          <a:p>
+            <a:pPr algn="ctr"/>
+          </a:p>
+        </p:txBody>
+      </p:sp>
+      <p:sp>
+        <p:nvSpPr>
+          <p:cNvPr id="8" name="TextBox 7"/>
+          <p:cNvSpPr txBox="1"/>
+          <p:nvPr/>
+        </p:nvSpPr>
+        <p:spPr>
+          <a:xfrm>
+            <a:off x="594360" y="1874519"/>
+            <a:ext cx="3291840" cy="1188720"/>
+          </a:xfrm>
+          <a:prstGeom prst="rect">
+            <a:avLst/>
+          </a:prstGeom>
+          <a:noFill/>
+        </p:spPr>
+        <p:txBody>
+          <a:bodyPr wrap="square">
+            <a:spAutoFit/>
+          </a:bodyPr>
+          <a:lstStyle/>
+          <a:p>
+            <a:pPr algn="ctr"/>
+            <a:r>
+              <a:rPr sz="1500" b="1" i="0">
+                <a:solidFill>
+                  <a:srgbClr val="1A1A2E"/>
+                </a:solidFill>
+              </a:rPr>
+              <a:t>「また食べちゃった…
+意志が弱い私ってダメだ」</a:t>
+            </a:r>
+          </a:p>
+        </p:txBody>
+      </p:sp>
+      <p:sp>
+        <p:nvSpPr>
+          <p:cNvPr id="9" name="Rectangle 8"/>
+          <p:cNvSpPr/>
+          <p:nvPr/>
+        </p:nvSpPr>
+        <p:spPr>
+          <a:xfrm>
+            <a:off x="4343400" y="1783080"/>
+            <a:ext cx="3566160" cy="1371600"/>
+          </a:xfrm>
+          <a:prstGeom prst="rect">
+            <a:avLst/>
+          </a:prstGeom>
+          <a:solidFill>
+            <a:srgbClr val="FFF0CC"/>
+          </a:solidFill>
+          <a:ln w="12700">
+            <a:solidFill>
+              <a:srgbClr val="6A1B9A"/>
+            </a:solidFill>
+          </a:ln>
+        </p:spPr>
+        <p:style>
+          <a:lnRef idx="1">
+            <a:schemeClr val="accent1"/>
+          </a:lnRef>
+          <a:fillRef idx="3">
+            <a:schemeClr val="accent1"/>
+          </a:fillRef>
+          <a:effectRef idx="2">
+            <a:schemeClr val="accent1"/>
+          </a:effectRef>
+          <a:fontRef idx="minor">
+            <a:schemeClr val="lt1"/>
+          </a:fontRef>
+        </p:style>
+        <p:txBody>
+          <a:bodyPr rtlCol="0" anchor="ctr"/>
+          <a:lstStyle/>
+          <a:p>
+            <a:pPr algn="ctr"/>
+          </a:p>
+        </p:txBody>
+      </p:sp>
+      <p:sp>
+        <p:nvSpPr>
+          <p:cNvPr id="10" name="TextBox 9"/>
+          <p:cNvSpPr txBox="1"/>
+          <p:nvPr/>
+        </p:nvSpPr>
+        <p:spPr>
+          <a:xfrm>
+            <a:off x="4480560" y="1874519"/>
+            <a:ext cx="3291840" cy="1188720"/>
+          </a:xfrm>
+          <a:prstGeom prst="rect">
+            <a:avLst/>
+          </a:prstGeom>
+          <a:noFill/>
+        </p:spPr>
+        <p:txBody>
+          <a:bodyPr wrap="square">
+            <a:spAutoFit/>
+          </a:bodyPr>
+          <a:lstStyle/>
+          <a:p>
+            <a:pPr algn="ctr"/>
+            <a:r>
+              <a:rPr sz="1500" b="1" i="0">
+                <a:solidFill>
+                  <a:srgbClr val="1A1A2E"/>
+                </a:solidFill>
+              </a:rPr>
+              <a:t>「運動しなきゃとは
+思ってるんだけど…」</a:t>
+            </a:r>
+          </a:p>
+        </p:txBody>
+      </p:sp>
+      <p:sp>
+        <p:nvSpPr>
+          <p:cNvPr id="11" name="Rectangle 10"/>
+          <p:cNvSpPr/>
+          <p:nvPr/>
+        </p:nvSpPr>
+        <p:spPr>
+          <a:xfrm>
+            <a:off x="8229600" y="1783080"/>
+            <a:ext cx="3566160" cy="1371600"/>
+          </a:xfrm>
+          <a:prstGeom prst="rect">
+            <a:avLst/>
+          </a:prstGeom>
+          <a:solidFill>
+            <a:srgbClr val="E8F5E9"/>
+          </a:solidFill>
+          <a:ln w="12700">
+            <a:solidFill>
+              <a:srgbClr val="6A1B9A"/>
+            </a:solidFill>
+          </a:ln>
+        </p:spPr>
+        <p:style>
+          <a:lnRef idx="1">
+            <a:schemeClr val="accent1"/>
+          </a:lnRef>
+          <a:fillRef idx="3">
+            <a:schemeClr val="accent1"/>
+          </a:fillRef>
+          <a:effectRef idx="2">
+            <a:schemeClr val="accent1"/>
+          </a:effectRef>
+          <a:fontRef idx="minor">
+            <a:schemeClr val="lt1"/>
+          </a:fontRef>
+        </p:style>
+        <p:txBody>
+          <a:bodyPr rtlCol="0" anchor="ctr"/>
+          <a:lstStyle/>
+          <a:p>
+            <a:pPr algn="ctr"/>
+          </a:p>
+        </p:txBody>
+      </p:sp>
+      <p:sp>
+        <p:nvSpPr>
+          <p:cNvPr id="12" name="TextBox 11"/>
+          <p:cNvSpPr txBox="1"/>
+          <p:nvPr/>
+        </p:nvSpPr>
+        <p:spPr>
+          <a:xfrm>
+            <a:off x="8366760" y="1874519"/>
+            <a:ext cx="3291840" cy="1188720"/>
+          </a:xfrm>
+          <a:prstGeom prst="rect">
+            <a:avLst/>
+          </a:prstGeom>
+          <a:noFill/>
+        </p:spPr>
+        <p:txBody>
+          <a:bodyPr wrap="square">
+            <a:spAutoFit/>
+          </a:bodyPr>
+          <a:lstStyle/>
+          <a:p>
+            <a:pPr algn="ctr"/>
+            <a:r>
+              <a:rPr sz="1500" b="1" i="0">
+                <a:solidFill>
+                  <a:srgbClr val="1A1A2E"/>
+                </a:solidFill>
+              </a:rPr>
+              <a:t>「わかってるけど
+できない、がずっと続いてる」</a:t>
+            </a:r>
+          </a:p>
+        </p:txBody>
+      </p:sp>
+      <p:sp>
+        <p:nvSpPr>
+          <p:cNvPr id="13" name="TextBox 12"/>
+          <p:cNvSpPr txBox="1"/>
+          <p:nvPr/>
+        </p:nvSpPr>
+        <p:spPr>
+          <a:xfrm>
+            <a:off x="457200" y="3246120"/>
+            <a:ext cx="11247120" cy="457200"/>
+          </a:xfrm>
+          <a:prstGeom prst="rect">
+            <a:avLst/>
+          </a:prstGeom>
+          <a:noFill/>
+        </p:spPr>
+        <p:txBody>
+          <a:bodyPr wrap="square">
+            <a:spAutoFit/>
+          </a:bodyPr>
+          <a:lstStyle/>
+          <a:p>
+            <a:pPr algn="ctr"/>
+            <a:r>
+              <a:rPr sz="1500" b="0" i="1">
+                <a:solidFill>
+                  <a:srgbClr val="757575"/>
+                </a:solidFill>
+              </a:rPr>
+              <a:t>↑ これが「Have to（〜しなければ）」思考のサイン</a:t>
+            </a:r>
+          </a:p>
+        </p:txBody>
+      </p:sp>
+      <p:sp>
+        <p:nvSpPr>
+          <p:cNvPr id="14" name="Rectangle 13"/>
+          <p:cNvSpPr/>
+          <p:nvPr/>
+        </p:nvSpPr>
+        <p:spPr>
+          <a:xfrm>
+            <a:off x="365760" y="3794760"/>
+            <a:ext cx="11430000" cy="73152"/>
+          </a:xfrm>
+          <a:prstGeom prst="rect">
+            <a:avLst/>
+          </a:prstGeom>
+          <a:solidFill>
+            <a:srgbClr val="CE93D8"/>
+          </a:solidFill>
+          <a:ln>
+            <a:noFill/>
+          </a:ln>
+        </p:spPr>
+        <p:style>
+          <a:lnRef idx="1">
+            <a:schemeClr val="accent1"/>
+          </a:lnRef>
+          <a:fillRef idx="3">
+            <a:schemeClr val="accent1"/>
+          </a:fillRef>
+          <a:effectRef idx="2">
+            <a:schemeClr val="accent1"/>
+          </a:effectRef>
+          <a:fontRef idx="minor">
+            <a:schemeClr val="lt1"/>
+          </a:fontRef>
+        </p:style>
+        <p:txBody>
+          <a:bodyPr rtlCol="0" anchor="ctr"/>
+          <a:lstStyle/>
+          <a:p>
+            <a:pPr algn="ctr"/>
+          </a:p>
+        </p:txBody>
+      </p:sp>
+      <p:sp>
+        <p:nvSpPr>
+          <p:cNvPr id="15" name="TextBox 14"/>
+          <p:cNvSpPr txBox="1"/>
+          <p:nvPr/>
+        </p:nvSpPr>
+        <p:spPr>
+          <a:xfrm>
+            <a:off x="457200" y="3931920"/>
+            <a:ext cx="11155680" cy="457200"/>
+          </a:xfrm>
+          <a:prstGeom prst="rect">
+            <a:avLst/>
+          </a:prstGeom>
+          <a:noFill/>
+        </p:spPr>
+        <p:txBody>
+          <a:bodyPr wrap="square">
+            <a:spAutoFit/>
+          </a:bodyPr>
+          <a:lstStyle/>
+          <a:p>
+            <a:pPr algn="ctr"/>
+            <a:r>
+              <a:rPr sz="1500" b="1" i="0">
+                <a:solidFill>
+                  <a:srgbClr val="6A1B9A"/>
+                </a:solidFill>
+              </a:rPr>
+              <a:t>カウンセリングで「なぜそうしたいのか」を一緒に掘り下げると……</a:t>
+            </a:r>
+          </a:p>
+        </p:txBody>
+      </p:sp>
+      <p:sp>
+        <p:nvSpPr>
+          <p:cNvPr id="16" name="Rectangle 15"/>
+          <p:cNvSpPr/>
+          <p:nvPr/>
+        </p:nvSpPr>
+        <p:spPr>
+          <a:xfrm>
+            <a:off x="365760" y="4462272"/>
+            <a:ext cx="5303520" cy="411480"/>
+          </a:xfrm>
+          <a:prstGeom prst="rect">
+            <a:avLst/>
+          </a:prstGeom>
+          <a:solidFill>
+            <a:srgbClr val="C62828"/>
+          </a:solidFill>
+          <a:ln>
+            <a:noFill/>
+          </a:ln>
+        </p:spPr>
+        <p:style>
+          <a:lnRef idx="1">
+            <a:schemeClr val="accent1"/>
+          </a:lnRef>
+          <a:fillRef idx="3">
+            <a:schemeClr val="accent1"/>
+          </a:fillRef>
+          <a:effectRef idx="2">
+            <a:schemeClr val="accent1"/>
+          </a:effectRef>
+          <a:fontRef idx="minor">
+            <a:schemeClr val="lt1"/>
+          </a:fontRef>
+        </p:style>
+        <p:txBody>
+          <a:bodyPr rtlCol="0" anchor="ctr"/>
+          <a:lstStyle/>
+          <a:p>
+            <a:pPr algn="ctr"/>
+          </a:p>
+        </p:txBody>
+      </p:sp>
+      <p:sp>
+        <p:nvSpPr>
+          <p:cNvPr id="17" name="Rectangle 16"/>
+          <p:cNvSpPr/>
+          <p:nvPr/>
+        </p:nvSpPr>
+        <p:spPr>
+          <a:xfrm>
+            <a:off x="6492240" y="4462272"/>
+            <a:ext cx="5303520" cy="411480"/>
+          </a:xfrm>
+          <a:prstGeom prst="rect">
+            <a:avLst/>
+          </a:prstGeom>
+          <a:solidFill>
+            <a:srgbClr val="2E7D32"/>
+          </a:solidFill>
+          <a:ln>
+            <a:noFill/>
+          </a:ln>
+        </p:spPr>
+        <p:style>
+          <a:lnRef idx="1">
+            <a:schemeClr val="accent1"/>
+          </a:lnRef>
+          <a:fillRef idx="3">
+            <a:schemeClr val="accent1"/>
+          </a:fillRef>
+          <a:effectRef idx="2">
+            <a:schemeClr val="accent1"/>
+          </a:effectRef>
+          <a:fontRef idx="minor">
+            <a:schemeClr val="lt1"/>
+          </a:fontRef>
+        </p:style>
+        <p:txBody>
+          <a:bodyPr rtlCol="0" anchor="ctr"/>
+          <a:lstStyle/>
+          <a:p>
+            <a:pPr algn="ctr"/>
+          </a:p>
+        </p:txBody>
+      </p:sp>
+      <p:sp>
+        <p:nvSpPr>
+          <p:cNvPr id="18" name="TextBox 17"/>
+          <p:cNvSpPr txBox="1"/>
+          <p:nvPr/>
+        </p:nvSpPr>
+        <p:spPr>
+          <a:xfrm>
+            <a:off x="457200" y="4480560"/>
+            <a:ext cx="5120640" cy="365760"/>
+          </a:xfrm>
+          <a:prstGeom prst="rect">
+            <a:avLst/>
+          </a:prstGeom>
+          <a:noFill/>
+        </p:spPr>
+        <p:txBody>
+          <a:bodyPr wrap="square">
+            <a:spAutoFit/>
+          </a:bodyPr>
+          <a:lstStyle/>
+          <a:p>
+            <a:pPr algn="ctr"/>
+            <a:r>
+              <a:rPr sz="1400" b="1" i="0">
+                <a:solidFill>
+                  <a:srgbClr val="FFFFFF"/>
+                </a:solidFill>
+              </a:rPr>
+              <a:t>❌  Have to（〜しなきゃ）</a:t>
+            </a:r>
+          </a:p>
+        </p:txBody>
+      </p:sp>
+      <p:sp>
+        <p:nvSpPr>
+          <p:cNvPr id="19" name="TextBox 18"/>
+          <p:cNvSpPr txBox="1"/>
+          <p:nvPr/>
+        </p:nvSpPr>
+        <p:spPr>
+          <a:xfrm>
+            <a:off x="6583680" y="4480560"/>
+            <a:ext cx="5120640" cy="365760"/>
+          </a:xfrm>
+          <a:prstGeom prst="rect">
+            <a:avLst/>
+          </a:prstGeom>
+          <a:noFill/>
+        </p:spPr>
+        <p:txBody>
+          <a:bodyPr wrap="square">
+            <a:spAutoFit/>
+          </a:bodyPr>
+          <a:lstStyle/>
+          <a:p>
+            <a:pPr algn="ctr"/>
+            <a:r>
+              <a:rPr sz="1400" b="1" i="0">
+                <a:solidFill>
+                  <a:srgbClr val="FFFFFF"/>
+                </a:solidFill>
+              </a:rPr>
+              <a:t>✅  Want to（〜したい！）</a:t>
+            </a:r>
+          </a:p>
+        </p:txBody>
+      </p:sp>
+      <p:sp>
+        <p:nvSpPr>
+          <p:cNvPr id="20" name="Rectangle 19"/>
+          <p:cNvSpPr/>
+          <p:nvPr/>
+        </p:nvSpPr>
+        <p:spPr>
+          <a:xfrm>
+            <a:off x="365760" y="4956048"/>
+            <a:ext cx="5303520" cy="512064"/>
+          </a:xfrm>
+          <a:prstGeom prst="rect">
+            <a:avLst/>
+          </a:prstGeom>
+          <a:solidFill>
+            <a:srgbClr val="FFEBEE"/>
+          </a:solidFill>
+          <a:ln>
+            <a:noFill/>
+          </a:ln>
+        </p:spPr>
+        <p:style>
+          <a:lnRef idx="1">
+            <a:schemeClr val="accent1"/>
+          </a:lnRef>
+          <a:fillRef idx="3">
+            <a:schemeClr val="accent1"/>
+          </a:fillRef>
+          <a:effectRef idx="2">
+            <a:schemeClr val="accent1"/>
+          </a:effectRef>
+          <a:fontRef idx="minor">
+            <a:schemeClr val="lt1"/>
+          </a:fontRef>
+        </p:style>
+        <p:txBody>
+          <a:bodyPr rtlCol="0" anchor="ctr"/>
+          <a:lstStyle/>
+          <a:p>
+            <a:pPr algn="ctr"/>
+          </a:p>
+        </p:txBody>
+      </p:sp>
+      <p:sp>
+        <p:nvSpPr>
+          <p:cNvPr id="21" name="Rectangle 20"/>
+          <p:cNvSpPr/>
+          <p:nvPr/>
+        </p:nvSpPr>
+        <p:spPr>
+          <a:xfrm>
+            <a:off x="6492240" y="4956048"/>
+            <a:ext cx="5303520" cy="512064"/>
+          </a:xfrm>
+          <a:prstGeom prst="rect">
+            <a:avLst/>
+          </a:prstGeom>
+          <a:solidFill>
+            <a:srgbClr val="E8F5E9"/>
+          </a:solidFill>
+          <a:ln>
+            <a:noFill/>
+          </a:ln>
+        </p:spPr>
+        <p:style>
+          <a:lnRef idx="1">
+            <a:schemeClr val="accent1"/>
+          </a:lnRef>
+          <a:fillRef idx="3">
+            <a:schemeClr val="accent1"/>
+          </a:fillRef>
+          <a:effectRef idx="2">
+            <a:schemeClr val="accent1"/>
+          </a:effectRef>
+          <a:fontRef idx="minor">
+            <a:schemeClr val="lt1"/>
+          </a:fontRef>
+        </p:style>
+        <p:txBody>
+          <a:bodyPr rtlCol="0" anchor="ctr"/>
+          <a:lstStyle/>
+          <a:p>
+            <a:pPr algn="ctr"/>
+          </a:p>
+        </p:txBody>
+      </p:sp>
+      <p:sp>
+        <p:nvSpPr>
+          <p:cNvPr id="22" name="TextBox 21"/>
+          <p:cNvSpPr txBox="1"/>
+          <p:nvPr/>
+        </p:nvSpPr>
+        <p:spPr>
+          <a:xfrm>
+            <a:off x="502920" y="5020056"/>
+            <a:ext cx="5029200" cy="411480"/>
+          </a:xfrm>
+          <a:prstGeom prst="rect">
+            <a:avLst/>
+          </a:prstGeom>
+          <a:noFill/>
+        </p:spPr>
+        <p:txBody>
+          <a:bodyPr wrap="square">
+            <a:spAutoFit/>
+          </a:bodyPr>
+          <a:lstStyle/>
+          <a:p>
+            <a:pPr algn="ctr"/>
+            <a:r>
+              <a:rPr sz="1300" b="0" i="0">
+                <a:solidFill>
+                  <a:srgbClr val="C62828"/>
+                </a:solidFill>
+              </a:rPr>
+              <a:t>「痩せなきゃいけない」</a:t>
+            </a:r>
+          </a:p>
+        </p:txBody>
+      </p:sp>
+      <p:sp>
+        <p:nvSpPr>
+          <p:cNvPr id="23" name="TextBox 22"/>
+          <p:cNvSpPr txBox="1"/>
+          <p:nvPr/>
+        </p:nvSpPr>
+        <p:spPr>
+          <a:xfrm>
+            <a:off x="6629400" y="5020056"/>
+            <a:ext cx="5029200" cy="411480"/>
+          </a:xfrm>
+          <a:prstGeom prst="rect">
+            <a:avLst/>
+          </a:prstGeom>
+          <a:noFill/>
+        </p:spPr>
+        <p:txBody>
+          <a:bodyPr wrap="square">
+            <a:spAutoFit/>
+          </a:bodyPr>
+          <a:lstStyle/>
+          <a:p>
+            <a:pPr algn="ctr"/>
+            <a:r>
+              <a:rPr sz="1300" b="1" i="0">
+                <a:solidFill>
+                  <a:srgbClr val="2E7D32"/>
+                </a:solidFill>
+              </a:rPr>
+              <a:t>「娘の結婚式に自信を持って立ちたい」</a:t>
+            </a:r>
+          </a:p>
+        </p:txBody>
+      </p:sp>
+      <p:sp>
+        <p:nvSpPr>
+          <p:cNvPr id="24" name="TextBox 23"/>
+          <p:cNvSpPr txBox="1"/>
+          <p:nvPr/>
+        </p:nvSpPr>
+        <p:spPr>
+          <a:xfrm>
+            <a:off x="5669280" y="5047488"/>
+            <a:ext cx="822960" cy="365760"/>
+          </a:xfrm>
+          <a:prstGeom prst="rect">
+            <a:avLst/>
+          </a:prstGeom>
+          <a:noFill/>
+        </p:spPr>
+        <p:txBody>
+          <a:bodyPr wrap="square">
+            <a:spAutoFit/>
+          </a:bodyPr>
+          <a:lstStyle/>
+          <a:p>
+            <a:pPr algn="ctr"/>
+            <a:r>
+              <a:rPr sz="2000" b="1" i="0">
+                <a:solidFill>
+                  <a:srgbClr val="757575"/>
+                </a:solidFill>
+              </a:rPr>
+              <a:t>→</a:t>
+            </a:r>
+          </a:p>
+        </p:txBody>
+      </p:sp>
+      <p:sp>
+        <p:nvSpPr>
+          <p:cNvPr id="25" name="Rectangle 24"/>
+          <p:cNvSpPr/>
+          <p:nvPr/>
+        </p:nvSpPr>
+        <p:spPr>
+          <a:xfrm>
+            <a:off x="365760" y="5522976"/>
+            <a:ext cx="5303520" cy="512064"/>
+          </a:xfrm>
+          <a:prstGeom prst="rect">
+            <a:avLst/>
+          </a:prstGeom>
+          <a:solidFill>
+            <a:srgbClr val="FFF8F8"/>
+          </a:solidFill>
+          <a:ln>
+            <a:noFill/>
+          </a:ln>
+        </p:spPr>
+        <p:style>
+          <a:lnRef idx="1">
+            <a:schemeClr val="accent1"/>
+          </a:lnRef>
+          <a:fillRef idx="3">
+            <a:schemeClr val="accent1"/>
+          </a:fillRef>
+          <a:effectRef idx="2">
+            <a:schemeClr val="accent1"/>
+          </a:effectRef>
+          <a:fontRef idx="minor">
+            <a:schemeClr val="lt1"/>
+          </a:fontRef>
+        </p:style>
+        <p:txBody>
+          <a:bodyPr rtlCol="0" anchor="ctr"/>
+          <a:lstStyle/>
+          <a:p>
+            <a:pPr algn="ctr"/>
+          </a:p>
+        </p:txBody>
+      </p:sp>
+      <p:sp>
+        <p:nvSpPr>
+          <p:cNvPr id="26" name="Rectangle 25"/>
+          <p:cNvSpPr/>
+          <p:nvPr/>
+        </p:nvSpPr>
+        <p:spPr>
+          <a:xfrm>
+            <a:off x="6492240" y="5522976"/>
+            <a:ext cx="5303520" cy="512064"/>
+          </a:xfrm>
+          <a:prstGeom prst="rect">
+            <a:avLst/>
+          </a:prstGeom>
+          <a:solidFill>
+            <a:srgbClr val="F1F8E9"/>
+          </a:solidFill>
+          <a:ln>
+            <a:noFill/>
+          </a:ln>
+        </p:spPr>
+        <p:style>
+          <a:lnRef idx="1">
+            <a:schemeClr val="accent1"/>
+          </a:lnRef>
+          <a:fillRef idx="3">
+            <a:schemeClr val="accent1"/>
+          </a:fillRef>
+          <a:effectRef idx="2">
+            <a:schemeClr val="accent1"/>
+          </a:effectRef>
+          <a:fontRef idx="minor">
+            <a:schemeClr val="lt1"/>
+          </a:fontRef>
+        </p:style>
+        <p:txBody>
+          <a:bodyPr rtlCol="0" anchor="ctr"/>
+          <a:lstStyle/>
+          <a:p>
+            <a:pPr algn="ctr"/>
+          </a:p>
+        </p:txBody>
+      </p:sp>
+      <p:sp>
+        <p:nvSpPr>
+          <p:cNvPr id="27" name="TextBox 26"/>
+          <p:cNvSpPr txBox="1"/>
+          <p:nvPr/>
+        </p:nvSpPr>
+        <p:spPr>
+          <a:xfrm>
+            <a:off x="502920" y="5586984"/>
+            <a:ext cx="5029200" cy="411480"/>
+          </a:xfrm>
+          <a:prstGeom prst="rect">
+            <a:avLst/>
+          </a:prstGeom>
+          <a:noFill/>
+        </p:spPr>
+        <p:txBody>
+          <a:bodyPr wrap="square">
+            <a:spAutoFit/>
+          </a:bodyPr>
+          <a:lstStyle/>
+          <a:p>
+            <a:pPr algn="ctr"/>
+            <a:r>
+              <a:rPr sz="1300" b="0" i="0">
+                <a:solidFill>
+                  <a:srgbClr val="C62828"/>
+                </a:solidFill>
+              </a:rPr>
+              <a:t>「食べるのを我慢しなきゃ」</a:t>
+            </a:r>
+          </a:p>
+        </p:txBody>
+      </p:sp>
+      <p:sp>
+        <p:nvSpPr>
+          <p:cNvPr id="28" name="TextBox 27"/>
+          <p:cNvSpPr txBox="1"/>
+          <p:nvPr/>
+        </p:nvSpPr>
+        <p:spPr>
+          <a:xfrm>
+            <a:off x="6629400" y="5586984"/>
+            <a:ext cx="5029200" cy="411480"/>
+          </a:xfrm>
+          <a:prstGeom prst="rect">
+            <a:avLst/>
+          </a:prstGeom>
+          <a:noFill/>
+        </p:spPr>
+        <p:txBody>
+          <a:bodyPr wrap="square">
+            <a:spAutoFit/>
+          </a:bodyPr>
+          <a:lstStyle/>
+          <a:p>
+            <a:pPr algn="ctr"/>
+            <a:r>
+              <a:rPr sz="1300" b="1" i="0">
+                <a:solidFill>
+                  <a:srgbClr val="2E7D32"/>
+                </a:solidFill>
+              </a:rPr>
+              <a:t>「体が軽くなった感覚をまた味わいたい」</a:t>
+            </a:r>
+          </a:p>
+        </p:txBody>
+      </p:sp>
+      <p:sp>
+        <p:nvSpPr>
+          <p:cNvPr id="29" name="TextBox 28"/>
+          <p:cNvSpPr txBox="1"/>
+          <p:nvPr/>
+        </p:nvSpPr>
+        <p:spPr>
+          <a:xfrm>
+            <a:off x="5669280" y="5614416"/>
+            <a:ext cx="822960" cy="365760"/>
+          </a:xfrm>
+          <a:prstGeom prst="rect">
+            <a:avLst/>
+          </a:prstGeom>
+          <a:noFill/>
+        </p:spPr>
+        <p:txBody>
+          <a:bodyPr wrap="square">
+            <a:spAutoFit/>
+          </a:bodyPr>
+          <a:lstStyle/>
+          <a:p>
+            <a:pPr algn="ctr"/>
+            <a:r>
+              <a:rPr sz="2000" b="1" i="0">
+                <a:solidFill>
+                  <a:srgbClr val="757575"/>
+                </a:solidFill>
+              </a:rPr>
+              <a:t>→</a:t>
+            </a:r>
+          </a:p>
+        </p:txBody>
+      </p:sp>
+      <p:sp>
+        <p:nvSpPr>
+          <p:cNvPr id="30" name="Rectangle 29"/>
+          <p:cNvSpPr/>
+          <p:nvPr/>
+        </p:nvSpPr>
+        <p:spPr>
+          <a:xfrm>
+            <a:off x="365760" y="6089904"/>
+            <a:ext cx="5303520" cy="512064"/>
+          </a:xfrm>
+          <a:prstGeom prst="rect">
+            <a:avLst/>
+          </a:prstGeom>
+          <a:solidFill>
+            <a:srgbClr val="FFEBEE"/>
+          </a:solidFill>
+          <a:ln>
+            <a:noFill/>
+          </a:ln>
+        </p:spPr>
+        <p:style>
+          <a:lnRef idx="1">
+            <a:schemeClr val="accent1"/>
+          </a:lnRef>
+          <a:fillRef idx="3">
+            <a:schemeClr val="accent1"/>
+          </a:fillRef>
+          <a:effectRef idx="2">
+            <a:schemeClr val="accent1"/>
+          </a:effectRef>
+          <a:fontRef idx="minor">
+            <a:schemeClr val="lt1"/>
+          </a:fontRef>
+        </p:style>
+        <p:txBody>
+          <a:bodyPr rtlCol="0" anchor="ctr"/>
+          <a:lstStyle/>
+          <a:p>
+            <a:pPr algn="ctr"/>
+          </a:p>
+        </p:txBody>
+      </p:sp>
+      <p:sp>
+        <p:nvSpPr>
+          <p:cNvPr id="31" name="Rectangle 30"/>
+          <p:cNvSpPr/>
+          <p:nvPr/>
+        </p:nvSpPr>
+        <p:spPr>
+          <a:xfrm>
+            <a:off x="6492240" y="6089904"/>
+            <a:ext cx="5303520" cy="512064"/>
+          </a:xfrm>
+          <a:prstGeom prst="rect">
+            <a:avLst/>
+          </a:prstGeom>
+          <a:solidFill>
+            <a:srgbClr val="E8F5E9"/>
+          </a:solidFill>
+          <a:ln>
+            <a:noFill/>
+          </a:ln>
+        </p:spPr>
+        <p:style>
+          <a:lnRef idx="1">
+            <a:schemeClr val="accent1"/>
+          </a:lnRef>
+          <a:fillRef idx="3">
+            <a:schemeClr val="accent1"/>
+          </a:fillRef>
+          <a:effectRef idx="2">
+            <a:schemeClr val="accent1"/>
+          </a:effectRef>
+          <a:fontRef idx="minor">
+            <a:schemeClr val="lt1"/>
+          </a:fontRef>
+        </p:style>
+        <p:txBody>
+          <a:bodyPr rtlCol="0" anchor="ctr"/>
+          <a:lstStyle/>
+          <a:p>
+            <a:pPr algn="ctr"/>
+          </a:p>
+        </p:txBody>
+      </p:sp>
+      <p:sp>
+        <p:nvSpPr>
+          <p:cNvPr id="32" name="TextBox 31"/>
+          <p:cNvSpPr txBox="1"/>
+          <p:nvPr/>
+        </p:nvSpPr>
+        <p:spPr>
+          <a:xfrm>
+            <a:off x="502920" y="6153912"/>
+            <a:ext cx="5029200" cy="411480"/>
+          </a:xfrm>
+          <a:prstGeom prst="rect">
+            <a:avLst/>
+          </a:prstGeom>
+          <a:noFill/>
+        </p:spPr>
+        <p:txBody>
+          <a:bodyPr wrap="square">
+            <a:spAutoFit/>
+          </a:bodyPr>
+          <a:lstStyle/>
+          <a:p>
+            <a:pPr algn="ctr"/>
+            <a:r>
+              <a:rPr sz="1300" b="0" i="0">
+                <a:solidFill>
+                  <a:srgbClr val="C62828"/>
+                </a:solidFill>
+              </a:rPr>
+              <a:t>「運動しなきゃ」</a:t>
+            </a:r>
+          </a:p>
+        </p:txBody>
+      </p:sp>
+      <p:sp>
+        <p:nvSpPr>
+          <p:cNvPr id="33" name="TextBox 32"/>
+          <p:cNvSpPr txBox="1"/>
+          <p:nvPr/>
+        </p:nvSpPr>
+        <p:spPr>
+          <a:xfrm>
+            <a:off x="6629400" y="6153912"/>
+            <a:ext cx="5029200" cy="411480"/>
+          </a:xfrm>
+          <a:prstGeom prst="rect">
+            <a:avLst/>
+          </a:prstGeom>
+          <a:noFill/>
+        </p:spPr>
+        <p:txBody>
+          <a:bodyPr wrap="square">
+            <a:spAutoFit/>
+          </a:bodyPr>
+          <a:lstStyle/>
+          <a:p>
+            <a:pPr algn="ctr"/>
+            <a:r>
+              <a:rPr sz="1300" b="1" i="0">
+                <a:solidFill>
+                  <a:srgbClr val="2E7D32"/>
+                </a:solidFill>
+              </a:rPr>
+              <a:t>「50代も元気でいたい。孫と走り回りたい」</a:t>
+            </a:r>
+          </a:p>
+        </p:txBody>
+      </p:sp>
+      <p:sp>
+        <p:nvSpPr>
+          <p:cNvPr id="34" name="TextBox 33"/>
+          <p:cNvSpPr txBox="1"/>
+          <p:nvPr/>
+        </p:nvSpPr>
+        <p:spPr>
+          <a:xfrm>
+            <a:off x="5669280" y="6181344"/>
+            <a:ext cx="822960" cy="365760"/>
+          </a:xfrm>
+          <a:prstGeom prst="rect">
+            <a:avLst/>
+          </a:prstGeom>
+          <a:noFill/>
+        </p:spPr>
+        <p:txBody>
+          <a:bodyPr wrap="square">
+            <a:spAutoFit/>
+          </a:bodyPr>
+          <a:lstStyle/>
+          <a:p>
+            <a:pPr algn="ctr"/>
+            <a:r>
+              <a:rPr sz="2000" b="1" i="0">
+                <a:solidFill>
+                  <a:srgbClr val="757575"/>
+                </a:solidFill>
+              </a:rPr>
+              <a:t>→</a:t>
+            </a:r>
+          </a:p>
+        </p:txBody>
+      </p:sp>
+      <p:sp>
+        <p:nvSpPr>
+          <p:cNvPr id="35" name="Rectangle 34"/>
+          <p:cNvSpPr/>
+          <p:nvPr/>
+        </p:nvSpPr>
+        <p:spPr>
+          <a:xfrm>
+            <a:off x="365760" y="6675120"/>
+            <a:ext cx="11430000" cy="137160"/>
+          </a:xfrm>
+          <a:prstGeom prst="rect">
+            <a:avLst/>
+          </a:prstGeom>
+          <a:solidFill>
+            <a:srgbClr val="6A1B9A"/>
+          </a:solidFill>
+          <a:ln>
+            <a:noFill/>
+          </a:ln>
+        </p:spPr>
+        <p:style>
+          <a:lnRef idx="1">
+            <a:schemeClr val="accent1"/>
+          </a:lnRef>
+          <a:fillRef idx="3">
+            <a:schemeClr val="accent1"/>
+          </a:fillRef>
+          <a:effectRef idx="2">
+            <a:schemeClr val="accent1"/>
+          </a:effectRef>
+          <a:fontRef idx="minor">
+            <a:schemeClr val="lt1"/>
+          </a:fontRef>
+        </p:style>
+        <p:txBody>
+          <a:bodyPr rtlCol="0" anchor="ctr"/>
+          <a:lstStyle/>
+          <a:p>
+            <a:pPr algn="ctr"/>
+          </a:p>
+        </p:txBody>
+      </p:sp>
+    </p:spTree>
+  </p:cSld>
+  <p:clrMapOvr>
+    <a:masterClrMapping/>
+  </p:clrMapOvr>
+</p:sld>
+</file>
+
+<file path=ppt/slides/slide15.xml><?xml version="1.0" encoding="utf-8"?>
+<p:sld xmlns:a="http://schemas.openxmlformats.org/drawingml/2006/main" xmlns:p="http://schemas.openxmlformats.org/presentationml/2006/main" xmlns:r="http://schemas.openxmlformats.org/officeDocument/2006/relationships">
+  <p:cSld>
+    <p:spTree>
+      <p:nvGrpSpPr>
+        <p:cNvPr id="1" name=""/>
+        <p:cNvGrpSpPr/>
+        <p:nvPr/>
+      </p:nvGrpSpPr>
+      <p:grpSpPr/>
+      <p:sp>
+        <p:nvSpPr>
+          <p:cNvPr id="2" name="Rectangle 1"/>
+          <p:cNvSpPr/>
+          <p:nvPr/>
+        </p:nvSpPr>
+        <p:spPr>
+          <a:xfrm>
+            <a:off x="0" y="0"/>
+            <a:ext cx="12188952" cy="6858000"/>
+          </a:xfrm>
+          <a:prstGeom prst="rect">
+            <a:avLst/>
+          </a:prstGeom>
+          <a:solidFill>
+            <a:srgbClr val="E8F5E9"/>
+          </a:solidFill>
+          <a:ln>
+            <a:noFill/>
+          </a:ln>
+        </p:spPr>
+        <p:style>
+          <a:lnRef idx="1">
+            <a:schemeClr val="accent1"/>
+          </a:lnRef>
+          <a:fillRef idx="3">
+            <a:schemeClr val="accent1"/>
+          </a:fillRef>
+          <a:effectRef idx="2">
+            <a:schemeClr val="accent1"/>
+          </a:effectRef>
+          <a:fontRef idx="minor">
+            <a:schemeClr val="lt1"/>
+          </a:fontRef>
+        </p:style>
+        <p:txBody>
+          <a:bodyPr rtlCol="0" anchor="ctr"/>
+          <a:lstStyle/>
+          <a:p>
+            <a:pPr algn="ctr"/>
+          </a:p>
+        </p:txBody>
+      </p:sp>
+      <p:sp>
+        <p:nvSpPr>
+          <p:cNvPr id="3" name="Rectangle 2"/>
+          <p:cNvSpPr/>
+          <p:nvPr/>
+        </p:nvSpPr>
+        <p:spPr>
+          <a:xfrm>
+            <a:off x="0" y="0"/>
+            <a:ext cx="12188952" cy="1051560"/>
+          </a:xfrm>
+          <a:prstGeom prst="rect">
+            <a:avLst/>
+          </a:prstGeom>
+          <a:solidFill>
+            <a:srgbClr val="2E7D32"/>
+          </a:solidFill>
+          <a:ln>
+            <a:noFill/>
+          </a:ln>
+        </p:spPr>
+        <p:style>
+          <a:lnRef idx="1">
+            <a:schemeClr val="accent1"/>
+          </a:lnRef>
+          <a:fillRef idx="3">
+            <a:schemeClr val="accent1"/>
+          </a:fillRef>
+          <a:effectRef idx="2">
+            <a:schemeClr val="accent1"/>
+          </a:effectRef>
+          <a:fontRef idx="minor">
+            <a:schemeClr val="lt1"/>
+          </a:fontRef>
+        </p:style>
+        <p:txBody>
+          <a:bodyPr rtlCol="0" anchor="ctr"/>
+          <a:lstStyle/>
+          <a:p>
+            <a:pPr algn="ctr"/>
+          </a:p>
+        </p:txBody>
+      </p:sp>
+      <p:sp>
+        <p:nvSpPr>
+          <p:cNvPr id="4" name="TextBox 3"/>
+          <p:cNvSpPr txBox="1"/>
+          <p:nvPr/>
+        </p:nvSpPr>
+        <p:spPr>
+          <a:xfrm>
+            <a:off x="365760" y="164592"/>
+            <a:ext cx="11430000" cy="731520"/>
+          </a:xfrm>
+          <a:prstGeom prst="rect">
+            <a:avLst/>
+          </a:prstGeom>
+          <a:noFill/>
+        </p:spPr>
+        <p:txBody>
+          <a:bodyPr wrap="square">
+            <a:spAutoFit/>
+          </a:bodyPr>
+          <a:lstStyle/>
+          <a:p>
+            <a:pPr algn="l"/>
+            <a:r>
+              <a:rPr sz="2600" b="1" i="0">
+                <a:solidFill>
+                  <a:srgbClr val="FFFFFF"/>
+                </a:solidFill>
+              </a:rPr>
+              <a:t>「Want to」を引き出すのが、カウンセラーの仕事</a:t>
+            </a:r>
+          </a:p>
+        </p:txBody>
+      </p:sp>
+      <p:sp>
+        <p:nvSpPr>
+          <p:cNvPr id="5" name="Rectangle 4"/>
+          <p:cNvSpPr/>
+          <p:nvPr/>
+        </p:nvSpPr>
+        <p:spPr>
+          <a:xfrm>
+            <a:off x="731520" y="1143000"/>
+            <a:ext cx="10698480" cy="960120"/>
+          </a:xfrm>
+          <a:prstGeom prst="rect">
+            <a:avLst/>
+          </a:prstGeom>
+          <a:solidFill>
+            <a:srgbClr val="2E7D32"/>
+          </a:solidFill>
+          <a:ln>
+            <a:noFill/>
+          </a:ln>
+        </p:spPr>
+        <p:style>
+          <a:lnRef idx="1">
+            <a:schemeClr val="accent1"/>
+          </a:lnRef>
+          <a:fillRef idx="3">
+            <a:schemeClr val="accent1"/>
+          </a:fillRef>
+          <a:effectRef idx="2">
+            <a:schemeClr val="accent1"/>
+          </a:effectRef>
+          <a:fontRef idx="minor">
+            <a:schemeClr val="lt1"/>
+          </a:fontRef>
+        </p:style>
+        <p:txBody>
+          <a:bodyPr rtlCol="0" anchor="ctr"/>
+          <a:lstStyle/>
+          <a:p>
+            <a:pPr algn="ctr"/>
+          </a:p>
+        </p:txBody>
+      </p:sp>
+      <p:sp>
+        <p:nvSpPr>
+          <p:cNvPr id="6" name="TextBox 5"/>
+          <p:cNvSpPr txBox="1"/>
+          <p:nvPr/>
+        </p:nvSpPr>
+        <p:spPr>
+          <a:xfrm>
+            <a:off x="914400" y="1170432"/>
+            <a:ext cx="10332720" cy="914400"/>
+          </a:xfrm>
+          <a:prstGeom prst="rect">
+            <a:avLst/>
+          </a:prstGeom>
+          <a:noFill/>
+        </p:spPr>
+        <p:txBody>
+          <a:bodyPr wrap="square">
+            <a:spAutoFit/>
+          </a:bodyPr>
+          <a:lstStyle/>
+          <a:p>
+            <a:pPr algn="ctr"/>
+            <a:r>
+              <a:rPr sz="1800" b="1" i="0">
+                <a:solidFill>
+                  <a:srgbClr val="FFFFFF"/>
+                </a:solidFill>
+              </a:rPr>
+              <a:t>「困っている人を探す」── その人が本当に叶えたいことを
+一緒に言語化することが、カウンセリングの出発点</a:t>
+            </a:r>
+          </a:p>
+        </p:txBody>
+      </p:sp>
+      <p:sp>
+        <p:nvSpPr>
+          <p:cNvPr id="7" name="TextBox 6"/>
+          <p:cNvSpPr txBox="1"/>
+          <p:nvPr/>
+        </p:nvSpPr>
+        <p:spPr>
+          <a:xfrm>
+            <a:off x="457200" y="2240280"/>
+            <a:ext cx="11247120" cy="457200"/>
+          </a:xfrm>
+          <a:prstGeom prst="rect">
+            <a:avLst/>
+          </a:prstGeom>
+          <a:noFill/>
+        </p:spPr>
+        <p:txBody>
+          <a:bodyPr wrap="square">
+            <a:spAutoFit/>
+          </a:bodyPr>
+          <a:lstStyle/>
+          <a:p>
+            <a:pPr algn="l"/>
+            <a:r>
+              <a:rPr sz="1500" b="1" i="0">
+                <a:solidFill>
+                  <a:srgbClr val="00898A"/>
+                </a:solidFill>
+              </a:rPr>
+              <a:t>実例：体重が落ちないと悩む40代女性へのカウンセリング</a:t>
+            </a:r>
+          </a:p>
+        </p:txBody>
+      </p:sp>
+      <p:sp>
+        <p:nvSpPr>
+          <p:cNvPr id="8" name="Rectangle 7"/>
+          <p:cNvSpPr/>
+          <p:nvPr/>
+        </p:nvSpPr>
+        <p:spPr>
+          <a:xfrm>
+            <a:off x="457200" y="2286000"/>
+            <a:ext cx="11247120" cy="45720"/>
+          </a:xfrm>
+          <a:prstGeom prst="rect">
+            <a:avLst/>
+          </a:prstGeom>
+          <a:solidFill>
+            <a:srgbClr val="00898A"/>
+          </a:solidFill>
+          <a:ln>
+            <a:noFill/>
+          </a:ln>
+        </p:spPr>
+        <p:style>
+          <a:lnRef idx="1">
+            <a:schemeClr val="accent1"/>
+          </a:lnRef>
+          <a:fillRef idx="3">
+            <a:schemeClr val="accent1"/>
+          </a:fillRef>
+          <a:effectRef idx="2">
+            <a:schemeClr val="accent1"/>
+          </a:effectRef>
+          <a:fontRef idx="minor">
+            <a:schemeClr val="lt1"/>
+          </a:fontRef>
+        </p:style>
+        <p:txBody>
+          <a:bodyPr rtlCol="0" anchor="ctr"/>
+          <a:lstStyle/>
+          <a:p>
+            <a:pPr algn="ctr"/>
+          </a:p>
+        </p:txBody>
+      </p:sp>
+      <p:sp>
+        <p:nvSpPr>
+          <p:cNvPr id="9" name="Rectangle 8"/>
+          <p:cNvSpPr/>
+          <p:nvPr/>
+        </p:nvSpPr>
+        <p:spPr>
+          <a:xfrm>
+            <a:off x="457200" y="2834640"/>
+            <a:ext cx="3566160" cy="3429000"/>
+          </a:xfrm>
+          <a:prstGeom prst="rect">
+            <a:avLst/>
+          </a:prstGeom>
+          <a:solidFill>
+            <a:srgbClr val="FFFFFF"/>
+          </a:solidFill>
+          <a:ln w="25400">
+            <a:solidFill>
+              <a:srgbClr val="FFB74D"/>
+            </a:solidFill>
+          </a:ln>
+        </p:spPr>
+        <p:style>
+          <a:lnRef idx="1">
+            <a:schemeClr val="accent1"/>
+          </a:lnRef>
+          <a:fillRef idx="3">
+            <a:schemeClr val="accent1"/>
+          </a:fillRef>
+          <a:effectRef idx="2">
+            <a:schemeClr val="accent1"/>
+          </a:effectRef>
+          <a:fontRef idx="minor">
+            <a:schemeClr val="lt1"/>
+          </a:fontRef>
+        </p:style>
+        <p:txBody>
+          <a:bodyPr rtlCol="0" anchor="ctr"/>
+          <a:lstStyle/>
+          <a:p>
+            <a:pPr algn="ctr"/>
+          </a:p>
+        </p:txBody>
+      </p:sp>
+      <p:sp>
+        <p:nvSpPr>
+          <p:cNvPr id="10" name="Rectangle 9"/>
+          <p:cNvSpPr/>
+          <p:nvPr/>
+        </p:nvSpPr>
+        <p:spPr>
+          <a:xfrm>
+            <a:off x="457200" y="2834640"/>
+            <a:ext cx="3566160" cy="685800"/>
+          </a:xfrm>
+          <a:prstGeom prst="rect">
+            <a:avLst/>
+          </a:prstGeom>
+          <a:solidFill>
+            <a:srgbClr val="FFB74D"/>
+          </a:solidFill>
+          <a:ln>
+            <a:noFill/>
+          </a:ln>
+        </p:spPr>
+        <p:style>
+          <a:lnRef idx="1">
+            <a:schemeClr val="accent1"/>
+          </a:lnRef>
+          <a:fillRef idx="3">
+            <a:schemeClr val="accent1"/>
+          </a:fillRef>
+          <a:effectRef idx="2">
+            <a:schemeClr val="accent1"/>
+          </a:effectRef>
+          <a:fontRef idx="minor">
+            <a:schemeClr val="lt1"/>
+          </a:fontRef>
+        </p:style>
+        <p:txBody>
+          <a:bodyPr rtlCol="0" anchor="ctr"/>
+          <a:lstStyle/>
+          <a:p>
+            <a:pPr algn="ctr"/>
+          </a:p>
+        </p:txBody>
+      </p:sp>
+      <p:sp>
+        <p:nvSpPr>
+          <p:cNvPr id="11" name="TextBox 10"/>
+          <p:cNvSpPr txBox="1"/>
+          <p:nvPr/>
+        </p:nvSpPr>
+        <p:spPr>
+          <a:xfrm>
+            <a:off x="502920" y="2880360"/>
+            <a:ext cx="685800" cy="594360"/>
+          </a:xfrm>
+          <a:prstGeom prst="rect">
+            <a:avLst/>
+          </a:prstGeom>
+          <a:noFill/>
+        </p:spPr>
+        <p:txBody>
+          <a:bodyPr wrap="square">
+            <a:spAutoFit/>
+          </a:bodyPr>
+          <a:lstStyle/>
+          <a:p>
+            <a:pPr algn="ctr"/>
+            <a:r>
+              <a:rPr sz="2600" b="0" i="0">
+                <a:solidFill>
+                  <a:srgbClr val="1A1A2E"/>
+                </a:solidFill>
+              </a:rPr>
+              <a:t>😔</a:t>
+            </a:r>
+          </a:p>
+        </p:txBody>
+      </p:sp>
+      <p:sp>
+        <p:nvSpPr>
+          <p:cNvPr id="12" name="TextBox 11"/>
+          <p:cNvSpPr txBox="1"/>
+          <p:nvPr/>
+        </p:nvSpPr>
+        <p:spPr>
+          <a:xfrm>
+            <a:off x="1143000" y="2907792"/>
+            <a:ext cx="2743200" cy="594360"/>
+          </a:xfrm>
+          <a:prstGeom prst="rect">
+            <a:avLst/>
+          </a:prstGeom>
+          <a:noFill/>
+        </p:spPr>
+        <p:txBody>
+          <a:bodyPr wrap="square">
+            <a:spAutoFit/>
+          </a:bodyPr>
+          <a:lstStyle/>
+          <a:p>
+            <a:pPr algn="l"/>
+            <a:r>
+              <a:rPr sz="1200" b="1" i="0">
+                <a:solidFill>
+                  <a:srgbClr val="FFFFFF"/>
+                </a:solidFill>
+              </a:rPr>
+              <a:t>STEP 1
+表面の悩みを聞く</a:t>
+            </a:r>
+          </a:p>
+        </p:txBody>
+      </p:sp>
+      <p:sp>
+        <p:nvSpPr>
+          <p:cNvPr id="13" name="TextBox 12"/>
+          <p:cNvSpPr txBox="1"/>
+          <p:nvPr/>
+        </p:nvSpPr>
+        <p:spPr>
+          <a:xfrm>
+            <a:off x="594360" y="3639312"/>
+            <a:ext cx="3291840" cy="2606040"/>
+          </a:xfrm>
+          <a:prstGeom prst="rect">
+            <a:avLst/>
+          </a:prstGeom>
+          <a:noFill/>
+        </p:spPr>
+        <p:txBody>
+          <a:bodyPr wrap="square">
+            <a:spAutoFit/>
+          </a:bodyPr>
+          <a:lstStyle/>
+          <a:p>
+            <a:pPr algn="l"/>
+            <a:r>
+              <a:rPr sz="1300" b="0" i="0">
+                <a:solidFill>
+                  <a:srgbClr val="1A1A2E"/>
+                </a:solidFill>
+              </a:rPr>
+              <a:t>「体重が減らない、ずっとリバウンドしている」
+→ 否定せず、まずそのまま受け取る</a:t>
+            </a:r>
+          </a:p>
+        </p:txBody>
+      </p:sp>
+      <p:sp>
+        <p:nvSpPr>
+          <p:cNvPr id="14" name="TextBox 13"/>
+          <p:cNvSpPr txBox="1"/>
+          <p:nvPr/>
+        </p:nvSpPr>
+        <p:spPr>
+          <a:xfrm>
+            <a:off x="3886200" y="4526280"/>
+            <a:ext cx="457200" cy="457200"/>
+          </a:xfrm>
+          <a:prstGeom prst="rect">
+            <a:avLst/>
+          </a:prstGeom>
+          <a:noFill/>
+        </p:spPr>
+        <p:txBody>
+          <a:bodyPr wrap="square">
+            <a:spAutoFit/>
+          </a:bodyPr>
+          <a:lstStyle/>
+          <a:p>
+            <a:pPr algn="ctr"/>
+            <a:r>
+              <a:rPr sz="2200" b="1" i="0">
+                <a:solidFill>
+                  <a:srgbClr val="757575"/>
+                </a:solidFill>
+              </a:rPr>
+              <a:t>→</a:t>
+            </a:r>
+          </a:p>
+        </p:txBody>
+      </p:sp>
+      <p:sp>
+        <p:nvSpPr>
+          <p:cNvPr id="15" name="Rectangle 14"/>
+          <p:cNvSpPr/>
+          <p:nvPr/>
+        </p:nvSpPr>
+        <p:spPr>
+          <a:xfrm>
+            <a:off x="4343400" y="2834640"/>
+            <a:ext cx="3566160" cy="3429000"/>
+          </a:xfrm>
+          <a:prstGeom prst="rect">
+            <a:avLst/>
+          </a:prstGeom>
+          <a:solidFill>
+            <a:srgbClr val="FFFFFF"/>
+          </a:solidFill>
+          <a:ln w="25400">
+            <a:solidFill>
+              <a:srgbClr val="00898A"/>
+            </a:solidFill>
+          </a:ln>
+        </p:spPr>
+        <p:style>
+          <a:lnRef idx="1">
+            <a:schemeClr val="accent1"/>
+          </a:lnRef>
+          <a:fillRef idx="3">
+            <a:schemeClr val="accent1"/>
+          </a:fillRef>
+          <a:effectRef idx="2">
+            <a:schemeClr val="accent1"/>
+          </a:effectRef>
+          <a:fontRef idx="minor">
+            <a:schemeClr val="lt1"/>
+          </a:fontRef>
+        </p:style>
+        <p:txBody>
+          <a:bodyPr rtlCol="0" anchor="ctr"/>
+          <a:lstStyle/>
+          <a:p>
+            <a:pPr algn="ctr"/>
+          </a:p>
+        </p:txBody>
+      </p:sp>
+      <p:sp>
+        <p:nvSpPr>
+          <p:cNvPr id="16" name="Rectangle 15"/>
+          <p:cNvSpPr/>
+          <p:nvPr/>
+        </p:nvSpPr>
+        <p:spPr>
+          <a:xfrm>
+            <a:off x="4343400" y="2834640"/>
+            <a:ext cx="3566160" cy="685800"/>
+          </a:xfrm>
+          <a:prstGeom prst="rect">
+            <a:avLst/>
+          </a:prstGeom>
+          <a:solidFill>
+            <a:srgbClr val="00898A"/>
+          </a:solidFill>
+          <a:ln>
+            <a:noFill/>
+          </a:ln>
+        </p:spPr>
+        <p:style>
+          <a:lnRef idx="1">
+            <a:schemeClr val="accent1"/>
+          </a:lnRef>
+          <a:fillRef idx="3">
+            <a:schemeClr val="accent1"/>
+          </a:fillRef>
+          <a:effectRef idx="2">
+            <a:schemeClr val="accent1"/>
+          </a:effectRef>
+          <a:fontRef idx="minor">
+            <a:schemeClr val="lt1"/>
+          </a:fontRef>
+        </p:style>
+        <p:txBody>
+          <a:bodyPr rtlCol="0" anchor="ctr"/>
+          <a:lstStyle/>
+          <a:p>
+            <a:pPr algn="ctr"/>
+          </a:p>
+        </p:txBody>
+      </p:sp>
+      <p:sp>
+        <p:nvSpPr>
+          <p:cNvPr id="17" name="TextBox 16"/>
+          <p:cNvSpPr txBox="1"/>
+          <p:nvPr/>
+        </p:nvSpPr>
+        <p:spPr>
+          <a:xfrm>
+            <a:off x="4389120" y="2880360"/>
+            <a:ext cx="685800" cy="594360"/>
+          </a:xfrm>
+          <a:prstGeom prst="rect">
+            <a:avLst/>
+          </a:prstGeom>
+          <a:noFill/>
+        </p:spPr>
+        <p:txBody>
+          <a:bodyPr wrap="square">
+            <a:spAutoFit/>
+          </a:bodyPr>
+          <a:lstStyle/>
+          <a:p>
+            <a:pPr algn="ctr"/>
+            <a:r>
+              <a:rPr sz="2600" b="0" i="0">
+                <a:solidFill>
+                  <a:srgbClr val="1A1A2E"/>
+                </a:solidFill>
+              </a:rPr>
+              <a:t>💬</a:t>
+            </a:r>
+          </a:p>
+        </p:txBody>
+      </p:sp>
+      <p:sp>
+        <p:nvSpPr>
+          <p:cNvPr id="18" name="TextBox 17"/>
+          <p:cNvSpPr txBox="1"/>
+          <p:nvPr/>
+        </p:nvSpPr>
+        <p:spPr>
+          <a:xfrm>
+            <a:off x="5029200" y="2907792"/>
+            <a:ext cx="2743200" cy="594360"/>
+          </a:xfrm>
+          <a:prstGeom prst="rect">
+            <a:avLst/>
+          </a:prstGeom>
+          <a:noFill/>
+        </p:spPr>
+        <p:txBody>
+          <a:bodyPr wrap="square">
+            <a:spAutoFit/>
+          </a:bodyPr>
+          <a:lstStyle/>
+          <a:p>
+            <a:pPr algn="l"/>
+            <a:r>
+              <a:rPr sz="1200" b="1" i="0">
+                <a:solidFill>
+                  <a:srgbClr val="FFFFFF"/>
+                </a:solidFill>
+              </a:rPr>
+              <a:t>STEP 2
+本当の気持ちを掘り下げる</a:t>
+            </a:r>
+          </a:p>
+        </p:txBody>
+      </p:sp>
+      <p:sp>
+        <p:nvSpPr>
+          <p:cNvPr id="19" name="TextBox 18"/>
+          <p:cNvSpPr txBox="1"/>
+          <p:nvPr/>
+        </p:nvSpPr>
+        <p:spPr>
+          <a:xfrm>
+            <a:off x="4480560" y="3639312"/>
+            <a:ext cx="3291840" cy="2606040"/>
+          </a:xfrm>
+          <a:prstGeom prst="rect">
+            <a:avLst/>
+          </a:prstGeom>
+          <a:noFill/>
+        </p:spPr>
+        <p:txBody>
+          <a:bodyPr wrap="square">
+            <a:spAutoFit/>
+          </a:bodyPr>
+          <a:lstStyle/>
+          <a:p>
+            <a:pPr algn="l"/>
+            <a:r>
+              <a:rPr sz="1300" b="0" i="0">
+                <a:solidFill>
+                  <a:srgbClr val="1A1A2E"/>
+                </a:solidFill>
+              </a:rPr>
+              <a:t>「どうして痩せたいんですか？」
+「もし叶ったら、どんな気持ちになりますか？」
+→ 「娘の成人式で一緒に写真を撮りたい」という言葉が出てきた</a:t>
+            </a:r>
+          </a:p>
+        </p:txBody>
+      </p:sp>
+      <p:sp>
+        <p:nvSpPr>
+          <p:cNvPr id="20" name="TextBox 19"/>
+          <p:cNvSpPr txBox="1"/>
+          <p:nvPr/>
+        </p:nvSpPr>
+        <p:spPr>
+          <a:xfrm>
+            <a:off x="7772400" y="4526280"/>
+            <a:ext cx="457200" cy="457200"/>
+          </a:xfrm>
+          <a:prstGeom prst="rect">
+            <a:avLst/>
+          </a:prstGeom>
+          <a:noFill/>
+        </p:spPr>
+        <p:txBody>
+          <a:bodyPr wrap="square">
+            <a:spAutoFit/>
+          </a:bodyPr>
+          <a:lstStyle/>
+          <a:p>
+            <a:pPr algn="ctr"/>
+            <a:r>
+              <a:rPr sz="2200" b="1" i="0">
+                <a:solidFill>
+                  <a:srgbClr val="757575"/>
+                </a:solidFill>
+              </a:rPr>
+              <a:t>→</a:t>
+            </a:r>
+          </a:p>
+        </p:txBody>
+      </p:sp>
+      <p:sp>
+        <p:nvSpPr>
+          <p:cNvPr id="21" name="Rectangle 20"/>
+          <p:cNvSpPr/>
+          <p:nvPr/>
+        </p:nvSpPr>
+        <p:spPr>
+          <a:xfrm>
+            <a:off x="8229600" y="2834640"/>
+            <a:ext cx="3566160" cy="3429000"/>
+          </a:xfrm>
+          <a:prstGeom prst="rect">
+            <a:avLst/>
+          </a:prstGeom>
+          <a:solidFill>
+            <a:srgbClr val="FFFFFF"/>
+          </a:solidFill>
+          <a:ln w="25400">
+            <a:solidFill>
+              <a:srgbClr val="2E7D32"/>
+            </a:solidFill>
+          </a:ln>
+        </p:spPr>
+        <p:style>
+          <a:lnRef idx="1">
+            <a:schemeClr val="accent1"/>
+          </a:lnRef>
+          <a:fillRef idx="3">
+            <a:schemeClr val="accent1"/>
+          </a:fillRef>
+          <a:effectRef idx="2">
+            <a:schemeClr val="accent1"/>
+          </a:effectRef>
+          <a:fontRef idx="minor">
+            <a:schemeClr val="lt1"/>
+          </a:fontRef>
+        </p:style>
+        <p:txBody>
+          <a:bodyPr rtlCol="0" anchor="ctr"/>
+          <a:lstStyle/>
+          <a:p>
+            <a:pPr algn="ctr"/>
+          </a:p>
+        </p:txBody>
+      </p:sp>
+      <p:sp>
+        <p:nvSpPr>
+          <p:cNvPr id="22" name="Rectangle 21"/>
+          <p:cNvSpPr/>
+          <p:nvPr/>
+        </p:nvSpPr>
+        <p:spPr>
+          <a:xfrm>
+            <a:off x="8229600" y="2834640"/>
+            <a:ext cx="3566160" cy="685800"/>
+          </a:xfrm>
+          <a:prstGeom prst="rect">
+            <a:avLst/>
+          </a:prstGeom>
+          <a:solidFill>
+            <a:srgbClr val="2E7D32"/>
+          </a:solidFill>
+          <a:ln>
+            <a:noFill/>
+          </a:ln>
+        </p:spPr>
+        <p:style>
+          <a:lnRef idx="1">
+            <a:schemeClr val="accent1"/>
+          </a:lnRef>
+          <a:fillRef idx="3">
+            <a:schemeClr val="accent1"/>
+          </a:fillRef>
+          <a:effectRef idx="2">
+            <a:schemeClr val="accent1"/>
+          </a:effectRef>
+          <a:fontRef idx="minor">
+            <a:schemeClr val="lt1"/>
+          </a:fontRef>
+        </p:style>
+        <p:txBody>
+          <a:bodyPr rtlCol="0" anchor="ctr"/>
+          <a:lstStyle/>
+          <a:p>
+            <a:pPr algn="ctr"/>
+          </a:p>
+        </p:txBody>
+      </p:sp>
+      <p:sp>
+        <p:nvSpPr>
+          <p:cNvPr id="23" name="TextBox 22"/>
+          <p:cNvSpPr txBox="1"/>
+          <p:nvPr/>
+        </p:nvSpPr>
+        <p:spPr>
+          <a:xfrm>
+            <a:off x="8275320" y="2880360"/>
+            <a:ext cx="685800" cy="594360"/>
+          </a:xfrm>
+          <a:prstGeom prst="rect">
+            <a:avLst/>
+          </a:prstGeom>
+          <a:noFill/>
+        </p:spPr>
+        <p:txBody>
+          <a:bodyPr wrap="square">
+            <a:spAutoFit/>
+          </a:bodyPr>
+          <a:lstStyle/>
+          <a:p>
+            <a:pPr algn="ctr"/>
+            <a:r>
+              <a:rPr sz="2600" b="0" i="0">
+                <a:solidFill>
+                  <a:srgbClr val="1A1A2E"/>
+                </a:solidFill>
+              </a:rPr>
+              <a:t>💚</a:t>
+            </a:r>
+          </a:p>
+        </p:txBody>
+      </p:sp>
+      <p:sp>
+        <p:nvSpPr>
+          <p:cNvPr id="24" name="TextBox 23"/>
+          <p:cNvSpPr txBox="1"/>
+          <p:nvPr/>
+        </p:nvSpPr>
+        <p:spPr>
+          <a:xfrm>
+            <a:off x="8915400" y="2907792"/>
+            <a:ext cx="2743200" cy="594360"/>
+          </a:xfrm>
+          <a:prstGeom prst="rect">
+            <a:avLst/>
+          </a:prstGeom>
+          <a:noFill/>
+        </p:spPr>
+        <p:txBody>
+          <a:bodyPr wrap="square">
+            <a:spAutoFit/>
+          </a:bodyPr>
+          <a:lstStyle/>
+          <a:p>
+            <a:pPr algn="l"/>
+            <a:r>
+              <a:rPr sz="1200" b="1" i="0">
+                <a:solidFill>
+                  <a:srgbClr val="FFFFFF"/>
+                </a:solidFill>
+              </a:rPr>
+              <a:t>STEP 3
+Want toが生まれる</a:t>
+            </a:r>
+          </a:p>
+        </p:txBody>
+      </p:sp>
+      <p:sp>
+        <p:nvSpPr>
+          <p:cNvPr id="25" name="TextBox 24"/>
+          <p:cNvSpPr txBox="1"/>
+          <p:nvPr/>
+        </p:nvSpPr>
+        <p:spPr>
+          <a:xfrm>
+            <a:off x="8366760" y="3639312"/>
+            <a:ext cx="3291840" cy="2606040"/>
+          </a:xfrm>
+          <a:prstGeom prst="rect">
+            <a:avLst/>
+          </a:prstGeom>
+          <a:noFill/>
+        </p:spPr>
+        <p:txBody>
+          <a:bodyPr wrap="square">
+            <a:spAutoFit/>
+          </a:bodyPr>
+          <a:lstStyle/>
+          <a:p>
+            <a:pPr algn="l"/>
+            <a:r>
+              <a:rPr sz="1300" b="0" i="0">
+                <a:solidFill>
+                  <a:srgbClr val="1A1A2E"/>
+                </a:solidFill>
+              </a:rPr>
+              <a:t>「痩せなきゃ」が
+「娘との写真のために、体を整えたい！」に変わる
+→ 行動の源泉が「義務」から「愛情と喜び」へ</a:t>
+            </a:r>
+          </a:p>
+        </p:txBody>
+      </p:sp>
+      <p:sp>
+        <p:nvSpPr>
+          <p:cNvPr id="26" name="Rectangle 25"/>
+          <p:cNvSpPr/>
+          <p:nvPr/>
+        </p:nvSpPr>
+        <p:spPr>
+          <a:xfrm>
+            <a:off x="457200" y="6373368"/>
+            <a:ext cx="11247120" cy="429768"/>
+          </a:xfrm>
+          <a:prstGeom prst="rect">
+            <a:avLst/>
+          </a:prstGeom>
+          <a:solidFill>
+            <a:srgbClr val="2E7D32"/>
+          </a:solidFill>
+          <a:ln>
+            <a:noFill/>
+          </a:ln>
+        </p:spPr>
+        <p:style>
+          <a:lnRef idx="1">
+            <a:schemeClr val="accent1"/>
+          </a:lnRef>
+          <a:fillRef idx="3">
+            <a:schemeClr val="accent1"/>
+          </a:fillRef>
+          <a:effectRef idx="2">
+            <a:schemeClr val="accent1"/>
+          </a:effectRef>
+          <a:fontRef idx="minor">
+            <a:schemeClr val="lt1"/>
+          </a:fontRef>
+        </p:style>
+        <p:txBody>
+          <a:bodyPr rtlCol="0" anchor="ctr"/>
+          <a:lstStyle/>
+          <a:p>
+            <a:pPr algn="ctr"/>
+          </a:p>
+        </p:txBody>
+      </p:sp>
+      <p:sp>
+        <p:nvSpPr>
+          <p:cNvPr id="27" name="TextBox 26"/>
+          <p:cNvSpPr txBox="1"/>
+          <p:nvPr/>
+        </p:nvSpPr>
+        <p:spPr>
+          <a:xfrm>
+            <a:off x="640080" y="6391656"/>
+            <a:ext cx="10972800" cy="402336"/>
+          </a:xfrm>
+          <a:prstGeom prst="rect">
+            <a:avLst/>
+          </a:prstGeom>
+          <a:noFill/>
+        </p:spPr>
+        <p:txBody>
+          <a:bodyPr wrap="square">
+            <a:spAutoFit/>
+          </a:bodyPr>
+          <a:lstStyle/>
+          <a:p>
+            <a:pPr algn="ctr"/>
+            <a:r>
+              <a:rPr sz="1400" b="1" i="0">
+                <a:solidFill>
+                  <a:srgbClr val="FFFFFF"/>
+                </a:solidFill>
+              </a:rPr>
+              <a:t>「痩せたい」は入口。カウンセラーはその奥にある「Want to」を一緒に見つける人</a:t>
             </a:r>
           </a:p>
         </p:txBody>

</xml_diff>